<commit_message>
Venezuela: FEWS NET seasonal calendar digitized (bars from the image's pixels, to the half month) and redrawn in English and Spanish on the page and both decks; Spanish deck wording from review (el Guri, nororiente, año hidrológico, page terms); Spanish defaults for new text in the Spanish PowerPoint
Co-Authored-By: Claude Opus 5.5 <noreply@anthropic.com>
</commit_message>
<xml_diff>
--- a/docs/enso/ven/slides/es/venezuela-el-nino-2026-27-es.pptx
+++ b/docs/enso/ven/slides/es/venezuela-el-nino-2026-27-es.pptx
@@ -972,7 +972,7 @@
           <a:p>
             <a:r>
               <a:rPr lang="es-VE"/>
-              <a:t>Inundaciones: registros de DesInventar, cada año frente a los años de alrededor. Guri: altimetría satelital NASA G-REALM desde 1992. Vegetación: FPAR de JRC ASAP, noviembre–abril, desde 2000; 2023/24, un El Niño fuerte, no estuvo entre las peores.</a:t>
+              <a:t>Inundaciones: registros de DesInventar, cada año frente a los años vecinos. Guri: altimetría satelital NASA G-REALM desde 1992. Vegetación: FPAR de JRC ASAP, noviembre–abril, desde 2000; 2023/24, un El Niño fuerte, no estuvo entre las peores.</a:t>
             </a:r>
           </a:p>
         </p:txBody>
@@ -1043,7 +1043,7 @@
           <a:p>
             <a:r>
               <a:rPr lang="es-VE"/>
-              <a:t>El total de cada región en los meses transcurridos de este año de lluvias, como porcentaje de su normal de 1991–2020.</a:t>
+              <a:t>El total de cada región en los meses transcurridos de este año hidrológico, como porcentaje de su normal de 1991–2020.</a:t>
             </a:r>
           </a:p>
         </p:txBody>
@@ -1390,10 +1390,10 @@
           <a:lstStyle/>
           <a:p>
             <a:r>
-              <a:rPr lang="en-US" smtClean="0"/>
+              <a:rPr lang="es-VE" smtClean="0"/>
               <a:t>Click to edit Master title style</a:t>
             </a:r>
-            <a:endParaRPr lang="en-US"/>
+            <a:endParaRPr lang="es-VE"/>
           </a:p>
         </p:txBody>
       </p:sp>
@@ -1418,7 +1418,7 @@
           <a:lstStyle>
             <a:lvl1pPr marL="0" indent="0" algn="ctr">
               <a:buNone/>
-              <a:defRPr>
+              <a:defRPr lang="es-VE">
                 <a:solidFill>
                   <a:schemeClr val="tx1">
                     <a:tint val="75000"/>
@@ -1428,7 +1428,7 @@
             </a:lvl1pPr>
             <a:lvl2pPr marL="457200" indent="0" algn="ctr">
               <a:buNone/>
-              <a:defRPr>
+              <a:defRPr lang="es-VE">
                 <a:solidFill>
                   <a:schemeClr val="tx1">
                     <a:tint val="75000"/>
@@ -1438,7 +1438,7 @@
             </a:lvl2pPr>
             <a:lvl3pPr marL="914400" indent="0" algn="ctr">
               <a:buNone/>
-              <a:defRPr>
+              <a:defRPr lang="es-VE">
                 <a:solidFill>
                   <a:schemeClr val="tx1">
                     <a:tint val="75000"/>
@@ -1448,7 +1448,7 @@
             </a:lvl3pPr>
             <a:lvl4pPr marL="1371600" indent="0" algn="ctr">
               <a:buNone/>
-              <a:defRPr>
+              <a:defRPr lang="es-VE">
                 <a:solidFill>
                   <a:schemeClr val="tx1">
                     <a:tint val="75000"/>
@@ -1458,7 +1458,7 @@
             </a:lvl4pPr>
             <a:lvl5pPr marL="1828800" indent="0" algn="ctr">
               <a:buNone/>
-              <a:defRPr>
+              <a:defRPr lang="es-VE">
                 <a:solidFill>
                   <a:schemeClr val="tx1">
                     <a:tint val="75000"/>
@@ -1468,7 +1468,7 @@
             </a:lvl5pPr>
             <a:lvl6pPr marL="2286000" indent="0" algn="ctr">
               <a:buNone/>
-              <a:defRPr>
+              <a:defRPr lang="es-VE">
                 <a:solidFill>
                   <a:schemeClr val="tx1">
                     <a:tint val="75000"/>
@@ -1478,7 +1478,7 @@
             </a:lvl6pPr>
             <a:lvl7pPr marL="2743200" indent="0" algn="ctr">
               <a:buNone/>
-              <a:defRPr>
+              <a:defRPr lang="es-VE">
                 <a:solidFill>
                   <a:schemeClr val="tx1">
                     <a:tint val="75000"/>
@@ -1488,7 +1488,7 @@
             </a:lvl7pPr>
             <a:lvl8pPr marL="3200400" indent="0" algn="ctr">
               <a:buNone/>
-              <a:defRPr>
+              <a:defRPr lang="es-VE">
                 <a:solidFill>
                   <a:schemeClr val="tx1">
                     <a:tint val="75000"/>
@@ -1498,7 +1498,7 @@
             </a:lvl8pPr>
             <a:lvl9pPr marL="3657600" indent="0" algn="ctr">
               <a:buNone/>
-              <a:defRPr>
+              <a:defRPr lang="es-VE">
                 <a:solidFill>
                   <a:schemeClr val="tx1">
                     <a:tint val="75000"/>
@@ -1509,10 +1509,10 @@
           </a:lstStyle>
           <a:p>
             <a:r>
-              <a:rPr lang="en-US" smtClean="0"/>
+              <a:rPr lang="es-VE" smtClean="0"/>
               <a:t>Click to edit Master subtitle style</a:t>
             </a:r>
-            <a:endParaRPr lang="en-US"/>
+            <a:endParaRPr lang="es-VE"/>
           </a:p>
         </p:txBody>
       </p:sp>
@@ -1532,10 +1532,10 @@
           <a:lstStyle/>
           <a:p>
             <a:fld id="{5BCAD085-E8A6-8845-BD4E-CB4CCA059FC4}" type="datetimeFigureOut">
-              <a:rPr lang="en-US" smtClean="0"/>
+              <a:rPr lang="es-VE" smtClean="0"/>
               <a:t>1/27/13</a:t>
             </a:fld>
-            <a:endParaRPr lang="en-US"/>
+            <a:endParaRPr lang="es-VE"/>
           </a:p>
         </p:txBody>
       </p:sp>
@@ -1554,7 +1554,7 @@
           <a:bodyPr/>
           <a:lstStyle/>
           <a:p>
-            <a:endParaRPr lang="en-US"/>
+            <a:endParaRPr lang="es-VE"/>
           </a:p>
         </p:txBody>
       </p:sp>
@@ -1574,10 +1574,10 @@
           <a:lstStyle/>
           <a:p>
             <a:fld id="{C1FF6DA9-008F-8B48-92A6-B652298478BF}" type="slidenum">
-              <a:rPr lang="en-US" smtClean="0"/>
+              <a:rPr lang="es-VE" smtClean="0"/>
               <a:t>‹#›</a:t>
             </a:fld>
-            <a:endParaRPr lang="en-US"/>
+            <a:endParaRPr lang="es-VE"/>
           </a:p>
         </p:txBody>
       </p:sp>
@@ -1627,10 +1627,10 @@
           <a:lstStyle/>
           <a:p>
             <a:r>
-              <a:rPr lang="en-US" smtClean="0"/>
+              <a:rPr lang="es-VE" smtClean="0"/>
               <a:t>Click to edit Master title style</a:t>
             </a:r>
-            <a:endParaRPr lang="en-US"/>
+            <a:endParaRPr lang="es-VE"/>
           </a:p>
         </p:txBody>
       </p:sp>
@@ -1651,38 +1651,38 @@
           <a:p>
             <a:pPr lvl="0"/>
             <a:r>
-              <a:rPr lang="en-US" smtClean="0"/>
+              <a:rPr lang="es-VE" smtClean="0"/>
               <a:t>Click to edit Master text styles</a:t>
             </a:r>
           </a:p>
           <a:p>
             <a:pPr lvl="1"/>
             <a:r>
-              <a:rPr lang="en-US" smtClean="0"/>
+              <a:rPr lang="es-VE" smtClean="0"/>
               <a:t>Second level</a:t>
             </a:r>
           </a:p>
           <a:p>
             <a:pPr lvl="2"/>
             <a:r>
-              <a:rPr lang="en-US" smtClean="0"/>
+              <a:rPr lang="es-VE" smtClean="0"/>
               <a:t>Third level</a:t>
             </a:r>
           </a:p>
           <a:p>
             <a:pPr lvl="3"/>
             <a:r>
-              <a:rPr lang="en-US" smtClean="0"/>
+              <a:rPr lang="es-VE" smtClean="0"/>
               <a:t>Fourth level</a:t>
             </a:r>
           </a:p>
           <a:p>
             <a:pPr lvl="4"/>
             <a:r>
-              <a:rPr lang="en-US" smtClean="0"/>
+              <a:rPr lang="es-VE" smtClean="0"/>
               <a:t>Fifth level</a:t>
             </a:r>
-            <a:endParaRPr lang="en-US"/>
+            <a:endParaRPr lang="es-VE"/>
           </a:p>
         </p:txBody>
       </p:sp>
@@ -1702,10 +1702,10 @@
           <a:lstStyle/>
           <a:p>
             <a:fld id="{5BCAD085-E8A6-8845-BD4E-CB4CCA059FC4}" type="datetimeFigureOut">
-              <a:rPr lang="en-US" smtClean="0"/>
+              <a:rPr lang="es-VE" smtClean="0"/>
               <a:t>1/27/13</a:t>
             </a:fld>
-            <a:endParaRPr lang="en-US"/>
+            <a:endParaRPr lang="es-VE"/>
           </a:p>
         </p:txBody>
       </p:sp>
@@ -1724,7 +1724,7 @@
           <a:bodyPr/>
           <a:lstStyle/>
           <a:p>
-            <a:endParaRPr lang="en-US"/>
+            <a:endParaRPr lang="es-VE"/>
           </a:p>
         </p:txBody>
       </p:sp>
@@ -1744,10 +1744,10 @@
           <a:lstStyle/>
           <a:p>
             <a:fld id="{C1FF6DA9-008F-8B48-92A6-B652298478BF}" type="slidenum">
-              <a:rPr lang="en-US" smtClean="0"/>
+              <a:rPr lang="es-VE" smtClean="0"/>
               <a:t>‹#›</a:t>
             </a:fld>
-            <a:endParaRPr lang="en-US"/>
+            <a:endParaRPr lang="es-VE"/>
           </a:p>
         </p:txBody>
       </p:sp>
@@ -1802,10 +1802,10 @@
           <a:lstStyle/>
           <a:p>
             <a:r>
-              <a:rPr lang="en-US" smtClean="0"/>
+              <a:rPr lang="es-VE" smtClean="0"/>
               <a:t>Click to edit Master title style</a:t>
             </a:r>
-            <a:endParaRPr lang="en-US"/>
+            <a:endParaRPr lang="es-VE"/>
           </a:p>
         </p:txBody>
       </p:sp>
@@ -1831,38 +1831,38 @@
           <a:p>
             <a:pPr lvl="0"/>
             <a:r>
-              <a:rPr lang="en-US" smtClean="0"/>
+              <a:rPr lang="es-VE" smtClean="0"/>
               <a:t>Click to edit Master text styles</a:t>
             </a:r>
           </a:p>
           <a:p>
             <a:pPr lvl="1"/>
             <a:r>
-              <a:rPr lang="en-US" smtClean="0"/>
+              <a:rPr lang="es-VE" smtClean="0"/>
               <a:t>Second level</a:t>
             </a:r>
           </a:p>
           <a:p>
             <a:pPr lvl="2"/>
             <a:r>
-              <a:rPr lang="en-US" smtClean="0"/>
+              <a:rPr lang="es-VE" smtClean="0"/>
               <a:t>Third level</a:t>
             </a:r>
           </a:p>
           <a:p>
             <a:pPr lvl="3"/>
             <a:r>
-              <a:rPr lang="en-US" smtClean="0"/>
+              <a:rPr lang="es-VE" smtClean="0"/>
               <a:t>Fourth level</a:t>
             </a:r>
           </a:p>
           <a:p>
             <a:pPr lvl="4"/>
             <a:r>
-              <a:rPr lang="en-US" smtClean="0"/>
+              <a:rPr lang="es-VE" smtClean="0"/>
               <a:t>Fifth level</a:t>
             </a:r>
-            <a:endParaRPr lang="en-US"/>
+            <a:endParaRPr lang="es-VE"/>
           </a:p>
         </p:txBody>
       </p:sp>
@@ -1882,10 +1882,10 @@
           <a:lstStyle/>
           <a:p>
             <a:fld id="{5BCAD085-E8A6-8845-BD4E-CB4CCA059FC4}" type="datetimeFigureOut">
-              <a:rPr lang="en-US" smtClean="0"/>
+              <a:rPr lang="es-VE" smtClean="0"/>
               <a:t>1/27/13</a:t>
             </a:fld>
-            <a:endParaRPr lang="en-US"/>
+            <a:endParaRPr lang="es-VE"/>
           </a:p>
         </p:txBody>
       </p:sp>
@@ -1904,7 +1904,7 @@
           <a:bodyPr/>
           <a:lstStyle/>
           <a:p>
-            <a:endParaRPr lang="en-US"/>
+            <a:endParaRPr lang="es-VE"/>
           </a:p>
         </p:txBody>
       </p:sp>
@@ -1924,10 +1924,10 @@
           <a:lstStyle/>
           <a:p>
             <a:fld id="{C1FF6DA9-008F-8B48-92A6-B652298478BF}" type="slidenum">
-              <a:rPr lang="en-US" smtClean="0"/>
+              <a:rPr lang="es-VE" smtClean="0"/>
               <a:t>‹#›</a:t>
             </a:fld>
-            <a:endParaRPr lang="en-US"/>
+            <a:endParaRPr lang="es-VE"/>
           </a:p>
         </p:txBody>
       </p:sp>
@@ -1977,10 +1977,10 @@
           <a:lstStyle/>
           <a:p>
             <a:r>
-              <a:rPr lang="en-US" smtClean="0"/>
+              <a:rPr lang="es-VE" smtClean="0"/>
               <a:t>Click to edit Master title style</a:t>
             </a:r>
-            <a:endParaRPr lang="en-US"/>
+            <a:endParaRPr lang="es-VE"/>
           </a:p>
         </p:txBody>
       </p:sp>
@@ -2001,38 +2001,38 @@
           <a:p>
             <a:pPr lvl="0"/>
             <a:r>
-              <a:rPr lang="en-US" smtClean="0"/>
+              <a:rPr lang="es-VE" smtClean="0"/>
               <a:t>Click to edit Master text styles</a:t>
             </a:r>
           </a:p>
           <a:p>
             <a:pPr lvl="1"/>
             <a:r>
-              <a:rPr lang="en-US" smtClean="0"/>
+              <a:rPr lang="es-VE" smtClean="0"/>
               <a:t>Second level</a:t>
             </a:r>
           </a:p>
           <a:p>
             <a:pPr lvl="2"/>
             <a:r>
-              <a:rPr lang="en-US" smtClean="0"/>
+              <a:rPr lang="es-VE" smtClean="0"/>
               <a:t>Third level</a:t>
             </a:r>
           </a:p>
           <a:p>
             <a:pPr lvl="3"/>
             <a:r>
-              <a:rPr lang="en-US" smtClean="0"/>
+              <a:rPr lang="es-VE" smtClean="0"/>
               <a:t>Fourth level</a:t>
             </a:r>
           </a:p>
           <a:p>
             <a:pPr lvl="4"/>
             <a:r>
-              <a:rPr lang="en-US" smtClean="0"/>
+              <a:rPr lang="es-VE" smtClean="0"/>
               <a:t>Fifth level</a:t>
             </a:r>
-            <a:endParaRPr lang="en-US"/>
+            <a:endParaRPr lang="es-VE"/>
           </a:p>
         </p:txBody>
       </p:sp>
@@ -2052,10 +2052,10 @@
           <a:lstStyle/>
           <a:p>
             <a:fld id="{5BCAD085-E8A6-8845-BD4E-CB4CCA059FC4}" type="datetimeFigureOut">
-              <a:rPr lang="en-US" smtClean="0"/>
+              <a:rPr lang="es-VE" smtClean="0"/>
               <a:t>1/27/13</a:t>
             </a:fld>
-            <a:endParaRPr lang="en-US"/>
+            <a:endParaRPr lang="es-VE"/>
           </a:p>
         </p:txBody>
       </p:sp>
@@ -2074,7 +2074,7 @@
           <a:bodyPr/>
           <a:lstStyle/>
           <a:p>
-            <a:endParaRPr lang="en-US"/>
+            <a:endParaRPr lang="es-VE"/>
           </a:p>
         </p:txBody>
       </p:sp>
@@ -2094,10 +2094,10 @@
           <a:lstStyle/>
           <a:p>
             <a:fld id="{C1FF6DA9-008F-8B48-92A6-B652298478BF}" type="slidenum">
-              <a:rPr lang="en-US" smtClean="0"/>
+              <a:rPr lang="es-VE" smtClean="0"/>
               <a:t>‹#›</a:t>
             </a:fld>
-            <a:endParaRPr lang="en-US"/>
+            <a:endParaRPr lang="es-VE"/>
           </a:p>
         </p:txBody>
       </p:sp>
@@ -2151,15 +2151,15 @@
           <a:bodyPr anchor="t"/>
           <a:lstStyle>
             <a:lvl1pPr algn="l">
-              <a:defRPr sz="4000" b="1" cap="all"/>
+              <a:defRPr sz="4000" b="1" cap="all" lang="es-VE"/>
             </a:lvl1pPr>
           </a:lstStyle>
           <a:p>
             <a:r>
-              <a:rPr lang="en-US" smtClean="0"/>
+              <a:rPr lang="es-VE" smtClean="0"/>
               <a:t>Click to edit Master title style</a:t>
             </a:r>
-            <a:endParaRPr lang="en-US"/>
+            <a:endParaRPr lang="es-VE"/>
           </a:p>
         </p:txBody>
       </p:sp>
@@ -2184,7 +2184,7 @@
           <a:lstStyle>
             <a:lvl1pPr marL="0" indent="0">
               <a:buNone/>
-              <a:defRPr sz="2000">
+              <a:defRPr sz="2000" lang="es-VE">
                 <a:solidFill>
                   <a:schemeClr val="tx1">
                     <a:tint val="75000"/>
@@ -2194,7 +2194,7 @@
             </a:lvl1pPr>
             <a:lvl2pPr marL="457200" indent="0">
               <a:buNone/>
-              <a:defRPr sz="1800">
+              <a:defRPr sz="1800" lang="es-VE">
                 <a:solidFill>
                   <a:schemeClr val="tx1">
                     <a:tint val="75000"/>
@@ -2204,7 +2204,7 @@
             </a:lvl2pPr>
             <a:lvl3pPr marL="914400" indent="0">
               <a:buNone/>
-              <a:defRPr sz="1600">
+              <a:defRPr sz="1600" lang="es-VE">
                 <a:solidFill>
                   <a:schemeClr val="tx1">
                     <a:tint val="75000"/>
@@ -2214,7 +2214,7 @@
             </a:lvl3pPr>
             <a:lvl4pPr marL="1371600" indent="0">
               <a:buNone/>
-              <a:defRPr sz="1400">
+              <a:defRPr sz="1400" lang="es-VE">
                 <a:solidFill>
                   <a:schemeClr val="tx1">
                     <a:tint val="75000"/>
@@ -2224,7 +2224,7 @@
             </a:lvl4pPr>
             <a:lvl5pPr marL="1828800" indent="0">
               <a:buNone/>
-              <a:defRPr sz="1400">
+              <a:defRPr sz="1400" lang="es-VE">
                 <a:solidFill>
                   <a:schemeClr val="tx1">
                     <a:tint val="75000"/>
@@ -2234,7 +2234,7 @@
             </a:lvl5pPr>
             <a:lvl6pPr marL="2286000" indent="0">
               <a:buNone/>
-              <a:defRPr sz="1400">
+              <a:defRPr sz="1400" lang="es-VE">
                 <a:solidFill>
                   <a:schemeClr val="tx1">
                     <a:tint val="75000"/>
@@ -2244,7 +2244,7 @@
             </a:lvl6pPr>
             <a:lvl7pPr marL="2743200" indent="0">
               <a:buNone/>
-              <a:defRPr sz="1400">
+              <a:defRPr sz="1400" lang="es-VE">
                 <a:solidFill>
                   <a:schemeClr val="tx1">
                     <a:tint val="75000"/>
@@ -2254,7 +2254,7 @@
             </a:lvl7pPr>
             <a:lvl8pPr marL="3200400" indent="0">
               <a:buNone/>
-              <a:defRPr sz="1400">
+              <a:defRPr sz="1400" lang="es-VE">
                 <a:solidFill>
                   <a:schemeClr val="tx1">
                     <a:tint val="75000"/>
@@ -2264,7 +2264,7 @@
             </a:lvl8pPr>
             <a:lvl9pPr marL="3657600" indent="0">
               <a:buNone/>
-              <a:defRPr sz="1400">
+              <a:defRPr sz="1400" lang="es-VE">
                 <a:solidFill>
                   <a:schemeClr val="tx1">
                     <a:tint val="75000"/>
@@ -2276,7 +2276,7 @@
           <a:p>
             <a:pPr lvl="0"/>
             <a:r>
-              <a:rPr lang="en-US" smtClean="0"/>
+              <a:rPr lang="es-VE" smtClean="0"/>
               <a:t>Click to edit Master text styles</a:t>
             </a:r>
           </a:p>
@@ -2298,10 +2298,10 @@
           <a:lstStyle/>
           <a:p>
             <a:fld id="{5BCAD085-E8A6-8845-BD4E-CB4CCA059FC4}" type="datetimeFigureOut">
-              <a:rPr lang="en-US" smtClean="0"/>
+              <a:rPr lang="es-VE" smtClean="0"/>
               <a:t>1/27/13</a:t>
             </a:fld>
-            <a:endParaRPr lang="en-US"/>
+            <a:endParaRPr lang="es-VE"/>
           </a:p>
         </p:txBody>
       </p:sp>
@@ -2320,7 +2320,7 @@
           <a:bodyPr/>
           <a:lstStyle/>
           <a:p>
-            <a:endParaRPr lang="en-US"/>
+            <a:endParaRPr lang="es-VE"/>
           </a:p>
         </p:txBody>
       </p:sp>
@@ -2340,10 +2340,10 @@
           <a:lstStyle/>
           <a:p>
             <a:fld id="{C1FF6DA9-008F-8B48-92A6-B652298478BF}" type="slidenum">
-              <a:rPr lang="en-US" smtClean="0"/>
+              <a:rPr lang="es-VE" smtClean="0"/>
               <a:t>‹#›</a:t>
             </a:fld>
-            <a:endParaRPr lang="en-US"/>
+            <a:endParaRPr lang="es-VE"/>
           </a:p>
         </p:txBody>
       </p:sp>
@@ -2393,10 +2393,10 @@
           <a:lstStyle/>
           <a:p>
             <a:r>
-              <a:rPr lang="en-US" smtClean="0"/>
+              <a:rPr lang="es-VE" smtClean="0"/>
               <a:t>Click to edit Master title style</a:t>
             </a:r>
-            <a:endParaRPr lang="en-US"/>
+            <a:endParaRPr lang="es-VE"/>
           </a:p>
         </p:txBody>
       </p:sp>
@@ -2420,68 +2420,68 @@
           <a:bodyPr/>
           <a:lstStyle>
             <a:lvl1pPr>
-              <a:defRPr sz="2800"/>
+              <a:defRPr sz="2800" lang="es-VE"/>
             </a:lvl1pPr>
             <a:lvl2pPr>
-              <a:defRPr sz="2400"/>
+              <a:defRPr sz="2400" lang="es-VE"/>
             </a:lvl2pPr>
             <a:lvl3pPr>
-              <a:defRPr sz="2000"/>
+              <a:defRPr sz="2000" lang="es-VE"/>
             </a:lvl3pPr>
             <a:lvl4pPr>
-              <a:defRPr sz="1800"/>
+              <a:defRPr sz="1800" lang="es-VE"/>
             </a:lvl4pPr>
             <a:lvl5pPr>
-              <a:defRPr sz="1800"/>
+              <a:defRPr sz="1800" lang="es-VE"/>
             </a:lvl5pPr>
             <a:lvl6pPr>
-              <a:defRPr sz="1800"/>
+              <a:defRPr sz="1800" lang="es-VE"/>
             </a:lvl6pPr>
             <a:lvl7pPr>
-              <a:defRPr sz="1800"/>
+              <a:defRPr sz="1800" lang="es-VE"/>
             </a:lvl7pPr>
             <a:lvl8pPr>
-              <a:defRPr sz="1800"/>
+              <a:defRPr sz="1800" lang="es-VE"/>
             </a:lvl8pPr>
             <a:lvl9pPr>
-              <a:defRPr sz="1800"/>
+              <a:defRPr sz="1800" lang="es-VE"/>
             </a:lvl9pPr>
           </a:lstStyle>
           <a:p>
             <a:pPr lvl="0"/>
             <a:r>
-              <a:rPr lang="en-US" smtClean="0"/>
+              <a:rPr lang="es-VE" smtClean="0"/>
               <a:t>Click to edit Master text styles</a:t>
             </a:r>
           </a:p>
           <a:p>
             <a:pPr lvl="1"/>
             <a:r>
-              <a:rPr lang="en-US" smtClean="0"/>
+              <a:rPr lang="es-VE" smtClean="0"/>
               <a:t>Second level</a:t>
             </a:r>
           </a:p>
           <a:p>
             <a:pPr lvl="2"/>
             <a:r>
-              <a:rPr lang="en-US" smtClean="0"/>
+              <a:rPr lang="es-VE" smtClean="0"/>
               <a:t>Third level</a:t>
             </a:r>
           </a:p>
           <a:p>
             <a:pPr lvl="3"/>
             <a:r>
-              <a:rPr lang="en-US" smtClean="0"/>
+              <a:rPr lang="es-VE" smtClean="0"/>
               <a:t>Fourth level</a:t>
             </a:r>
           </a:p>
           <a:p>
             <a:pPr lvl="4"/>
             <a:r>
-              <a:rPr lang="en-US" smtClean="0"/>
+              <a:rPr lang="es-VE" smtClean="0"/>
               <a:t>Fifth level</a:t>
             </a:r>
-            <a:endParaRPr lang="en-US"/>
+            <a:endParaRPr lang="es-VE"/>
           </a:p>
         </p:txBody>
       </p:sp>
@@ -2505,68 +2505,68 @@
           <a:bodyPr/>
           <a:lstStyle>
             <a:lvl1pPr>
-              <a:defRPr sz="2800"/>
+              <a:defRPr sz="2800" lang="es-VE"/>
             </a:lvl1pPr>
             <a:lvl2pPr>
-              <a:defRPr sz="2400"/>
+              <a:defRPr sz="2400" lang="es-VE"/>
             </a:lvl2pPr>
             <a:lvl3pPr>
-              <a:defRPr sz="2000"/>
+              <a:defRPr sz="2000" lang="es-VE"/>
             </a:lvl3pPr>
             <a:lvl4pPr>
-              <a:defRPr sz="1800"/>
+              <a:defRPr sz="1800" lang="es-VE"/>
             </a:lvl4pPr>
             <a:lvl5pPr>
-              <a:defRPr sz="1800"/>
+              <a:defRPr sz="1800" lang="es-VE"/>
             </a:lvl5pPr>
             <a:lvl6pPr>
-              <a:defRPr sz="1800"/>
+              <a:defRPr sz="1800" lang="es-VE"/>
             </a:lvl6pPr>
             <a:lvl7pPr>
-              <a:defRPr sz="1800"/>
+              <a:defRPr sz="1800" lang="es-VE"/>
             </a:lvl7pPr>
             <a:lvl8pPr>
-              <a:defRPr sz="1800"/>
+              <a:defRPr sz="1800" lang="es-VE"/>
             </a:lvl8pPr>
             <a:lvl9pPr>
-              <a:defRPr sz="1800"/>
+              <a:defRPr sz="1800" lang="es-VE"/>
             </a:lvl9pPr>
           </a:lstStyle>
           <a:p>
             <a:pPr lvl="0"/>
             <a:r>
-              <a:rPr lang="en-US" smtClean="0"/>
+              <a:rPr lang="es-VE" smtClean="0"/>
               <a:t>Click to edit Master text styles</a:t>
             </a:r>
           </a:p>
           <a:p>
             <a:pPr lvl="1"/>
             <a:r>
-              <a:rPr lang="en-US" smtClean="0"/>
+              <a:rPr lang="es-VE" smtClean="0"/>
               <a:t>Second level</a:t>
             </a:r>
           </a:p>
           <a:p>
             <a:pPr lvl="2"/>
             <a:r>
-              <a:rPr lang="en-US" smtClean="0"/>
+              <a:rPr lang="es-VE" smtClean="0"/>
               <a:t>Third level</a:t>
             </a:r>
           </a:p>
           <a:p>
             <a:pPr lvl="3"/>
             <a:r>
-              <a:rPr lang="en-US" smtClean="0"/>
+              <a:rPr lang="es-VE" smtClean="0"/>
               <a:t>Fourth level</a:t>
             </a:r>
           </a:p>
           <a:p>
             <a:pPr lvl="4"/>
             <a:r>
-              <a:rPr lang="en-US" smtClean="0"/>
+              <a:rPr lang="es-VE" smtClean="0"/>
               <a:t>Fifth level</a:t>
             </a:r>
-            <a:endParaRPr lang="en-US"/>
+            <a:endParaRPr lang="es-VE"/>
           </a:p>
         </p:txBody>
       </p:sp>
@@ -2586,10 +2586,10 @@
           <a:lstStyle/>
           <a:p>
             <a:fld id="{5BCAD085-E8A6-8845-BD4E-CB4CCA059FC4}" type="datetimeFigureOut">
-              <a:rPr lang="en-US" smtClean="0"/>
+              <a:rPr lang="es-VE" smtClean="0"/>
               <a:t>1/27/13</a:t>
             </a:fld>
-            <a:endParaRPr lang="en-US"/>
+            <a:endParaRPr lang="es-VE"/>
           </a:p>
         </p:txBody>
       </p:sp>
@@ -2608,7 +2608,7 @@
           <a:bodyPr/>
           <a:lstStyle/>
           <a:p>
-            <a:endParaRPr lang="en-US"/>
+            <a:endParaRPr lang="es-VE"/>
           </a:p>
         </p:txBody>
       </p:sp>
@@ -2628,10 +2628,10 @@
           <a:lstStyle/>
           <a:p>
             <a:fld id="{C1FF6DA9-008F-8B48-92A6-B652298478BF}" type="slidenum">
-              <a:rPr lang="en-US" smtClean="0"/>
+              <a:rPr lang="es-VE" smtClean="0"/>
               <a:t>‹#›</a:t>
             </a:fld>
-            <a:endParaRPr lang="en-US"/>
+            <a:endParaRPr lang="es-VE"/>
           </a:p>
         </p:txBody>
       </p:sp>
@@ -2680,15 +2680,15 @@
           <a:bodyPr/>
           <a:lstStyle>
             <a:lvl1pPr>
-              <a:defRPr/>
+              <a:defRPr lang="es-VE"/>
             </a:lvl1pPr>
           </a:lstStyle>
           <a:p>
             <a:r>
-              <a:rPr lang="en-US" smtClean="0"/>
+              <a:rPr lang="es-VE" smtClean="0"/>
               <a:t>Click to edit Master title style</a:t>
             </a:r>
-            <a:endParaRPr lang="en-US"/>
+            <a:endParaRPr lang="es-VE"/>
           </a:p>
         </p:txBody>
       </p:sp>
@@ -2713,45 +2713,45 @@
           <a:lstStyle>
             <a:lvl1pPr marL="0" indent="0">
               <a:buNone/>
-              <a:defRPr sz="2400" b="1"/>
+              <a:defRPr sz="2400" b="1" lang="es-VE"/>
             </a:lvl1pPr>
             <a:lvl2pPr marL="457200" indent="0">
               <a:buNone/>
-              <a:defRPr sz="2000" b="1"/>
+              <a:defRPr sz="2000" b="1" lang="es-VE"/>
             </a:lvl2pPr>
             <a:lvl3pPr marL="914400" indent="0">
               <a:buNone/>
-              <a:defRPr sz="1800" b="1"/>
+              <a:defRPr sz="1800" b="1" lang="es-VE"/>
             </a:lvl3pPr>
             <a:lvl4pPr marL="1371600" indent="0">
               <a:buNone/>
-              <a:defRPr sz="1600" b="1"/>
+              <a:defRPr sz="1600" b="1" lang="es-VE"/>
             </a:lvl4pPr>
             <a:lvl5pPr marL="1828800" indent="0">
               <a:buNone/>
-              <a:defRPr sz="1600" b="1"/>
+              <a:defRPr sz="1600" b="1" lang="es-VE"/>
             </a:lvl5pPr>
             <a:lvl6pPr marL="2286000" indent="0">
               <a:buNone/>
-              <a:defRPr sz="1600" b="1"/>
+              <a:defRPr sz="1600" b="1" lang="es-VE"/>
             </a:lvl6pPr>
             <a:lvl7pPr marL="2743200" indent="0">
               <a:buNone/>
-              <a:defRPr sz="1600" b="1"/>
+              <a:defRPr sz="1600" b="1" lang="es-VE"/>
             </a:lvl7pPr>
             <a:lvl8pPr marL="3200400" indent="0">
               <a:buNone/>
-              <a:defRPr sz="1600" b="1"/>
+              <a:defRPr sz="1600" b="1" lang="es-VE"/>
             </a:lvl8pPr>
             <a:lvl9pPr marL="3657600" indent="0">
               <a:buNone/>
-              <a:defRPr sz="1600" b="1"/>
+              <a:defRPr sz="1600" b="1" lang="es-VE"/>
             </a:lvl9pPr>
           </a:lstStyle>
           <a:p>
             <a:pPr lvl="0"/>
             <a:r>
-              <a:rPr lang="en-US" smtClean="0"/>
+              <a:rPr lang="es-VE" smtClean="0"/>
               <a:t>Click to edit Master text styles</a:t>
             </a:r>
           </a:p>
@@ -2777,68 +2777,68 @@
           <a:bodyPr/>
           <a:lstStyle>
             <a:lvl1pPr>
-              <a:defRPr sz="2400"/>
+              <a:defRPr sz="2400" lang="es-VE"/>
             </a:lvl1pPr>
             <a:lvl2pPr>
-              <a:defRPr sz="2000"/>
+              <a:defRPr sz="2000" lang="es-VE"/>
             </a:lvl2pPr>
             <a:lvl3pPr>
-              <a:defRPr sz="1800"/>
+              <a:defRPr sz="1800" lang="es-VE"/>
             </a:lvl3pPr>
             <a:lvl4pPr>
-              <a:defRPr sz="1600"/>
+              <a:defRPr sz="1600" lang="es-VE"/>
             </a:lvl4pPr>
             <a:lvl5pPr>
-              <a:defRPr sz="1600"/>
+              <a:defRPr sz="1600" lang="es-VE"/>
             </a:lvl5pPr>
             <a:lvl6pPr>
-              <a:defRPr sz="1600"/>
+              <a:defRPr sz="1600" lang="es-VE"/>
             </a:lvl6pPr>
             <a:lvl7pPr>
-              <a:defRPr sz="1600"/>
+              <a:defRPr sz="1600" lang="es-VE"/>
             </a:lvl7pPr>
             <a:lvl8pPr>
-              <a:defRPr sz="1600"/>
+              <a:defRPr sz="1600" lang="es-VE"/>
             </a:lvl8pPr>
             <a:lvl9pPr>
-              <a:defRPr sz="1600"/>
+              <a:defRPr sz="1600" lang="es-VE"/>
             </a:lvl9pPr>
           </a:lstStyle>
           <a:p>
             <a:pPr lvl="0"/>
             <a:r>
-              <a:rPr lang="en-US" smtClean="0"/>
+              <a:rPr lang="es-VE" smtClean="0"/>
               <a:t>Click to edit Master text styles</a:t>
             </a:r>
           </a:p>
           <a:p>
             <a:pPr lvl="1"/>
             <a:r>
-              <a:rPr lang="en-US" smtClean="0"/>
+              <a:rPr lang="es-VE" smtClean="0"/>
               <a:t>Second level</a:t>
             </a:r>
           </a:p>
           <a:p>
             <a:pPr lvl="2"/>
             <a:r>
-              <a:rPr lang="en-US" smtClean="0"/>
+              <a:rPr lang="es-VE" smtClean="0"/>
               <a:t>Third level</a:t>
             </a:r>
           </a:p>
           <a:p>
             <a:pPr lvl="3"/>
             <a:r>
-              <a:rPr lang="en-US" smtClean="0"/>
+              <a:rPr lang="es-VE" smtClean="0"/>
               <a:t>Fourth level</a:t>
             </a:r>
           </a:p>
           <a:p>
             <a:pPr lvl="4"/>
             <a:r>
-              <a:rPr lang="en-US" smtClean="0"/>
+              <a:rPr lang="es-VE" smtClean="0"/>
               <a:t>Fifth level</a:t>
             </a:r>
-            <a:endParaRPr lang="en-US"/>
+            <a:endParaRPr lang="es-VE"/>
           </a:p>
         </p:txBody>
       </p:sp>
@@ -2863,45 +2863,45 @@
           <a:lstStyle>
             <a:lvl1pPr marL="0" indent="0">
               <a:buNone/>
-              <a:defRPr sz="2400" b="1"/>
+              <a:defRPr sz="2400" b="1" lang="es-VE"/>
             </a:lvl1pPr>
             <a:lvl2pPr marL="457200" indent="0">
               <a:buNone/>
-              <a:defRPr sz="2000" b="1"/>
+              <a:defRPr sz="2000" b="1" lang="es-VE"/>
             </a:lvl2pPr>
             <a:lvl3pPr marL="914400" indent="0">
               <a:buNone/>
-              <a:defRPr sz="1800" b="1"/>
+              <a:defRPr sz="1800" b="1" lang="es-VE"/>
             </a:lvl3pPr>
             <a:lvl4pPr marL="1371600" indent="0">
               <a:buNone/>
-              <a:defRPr sz="1600" b="1"/>
+              <a:defRPr sz="1600" b="1" lang="es-VE"/>
             </a:lvl4pPr>
             <a:lvl5pPr marL="1828800" indent="0">
               <a:buNone/>
-              <a:defRPr sz="1600" b="1"/>
+              <a:defRPr sz="1600" b="1" lang="es-VE"/>
             </a:lvl5pPr>
             <a:lvl6pPr marL="2286000" indent="0">
               <a:buNone/>
-              <a:defRPr sz="1600" b="1"/>
+              <a:defRPr sz="1600" b="1" lang="es-VE"/>
             </a:lvl6pPr>
             <a:lvl7pPr marL="2743200" indent="0">
               <a:buNone/>
-              <a:defRPr sz="1600" b="1"/>
+              <a:defRPr sz="1600" b="1" lang="es-VE"/>
             </a:lvl7pPr>
             <a:lvl8pPr marL="3200400" indent="0">
               <a:buNone/>
-              <a:defRPr sz="1600" b="1"/>
+              <a:defRPr sz="1600" b="1" lang="es-VE"/>
             </a:lvl8pPr>
             <a:lvl9pPr marL="3657600" indent="0">
               <a:buNone/>
-              <a:defRPr sz="1600" b="1"/>
+              <a:defRPr sz="1600" b="1" lang="es-VE"/>
             </a:lvl9pPr>
           </a:lstStyle>
           <a:p>
             <a:pPr lvl="0"/>
             <a:r>
-              <a:rPr lang="en-US" smtClean="0"/>
+              <a:rPr lang="es-VE" smtClean="0"/>
               <a:t>Click to edit Master text styles</a:t>
             </a:r>
           </a:p>
@@ -2927,68 +2927,68 @@
           <a:bodyPr/>
           <a:lstStyle>
             <a:lvl1pPr>
-              <a:defRPr sz="2400"/>
+              <a:defRPr sz="2400" lang="es-VE"/>
             </a:lvl1pPr>
             <a:lvl2pPr>
-              <a:defRPr sz="2000"/>
+              <a:defRPr sz="2000" lang="es-VE"/>
             </a:lvl2pPr>
             <a:lvl3pPr>
-              <a:defRPr sz="1800"/>
+              <a:defRPr sz="1800" lang="es-VE"/>
             </a:lvl3pPr>
             <a:lvl4pPr>
-              <a:defRPr sz="1600"/>
+              <a:defRPr sz="1600" lang="es-VE"/>
             </a:lvl4pPr>
             <a:lvl5pPr>
-              <a:defRPr sz="1600"/>
+              <a:defRPr sz="1600" lang="es-VE"/>
             </a:lvl5pPr>
             <a:lvl6pPr>
-              <a:defRPr sz="1600"/>
+              <a:defRPr sz="1600" lang="es-VE"/>
             </a:lvl6pPr>
             <a:lvl7pPr>
-              <a:defRPr sz="1600"/>
+              <a:defRPr sz="1600" lang="es-VE"/>
             </a:lvl7pPr>
             <a:lvl8pPr>
-              <a:defRPr sz="1600"/>
+              <a:defRPr sz="1600" lang="es-VE"/>
             </a:lvl8pPr>
             <a:lvl9pPr>
-              <a:defRPr sz="1600"/>
+              <a:defRPr sz="1600" lang="es-VE"/>
             </a:lvl9pPr>
           </a:lstStyle>
           <a:p>
             <a:pPr lvl="0"/>
             <a:r>
-              <a:rPr lang="en-US" smtClean="0"/>
+              <a:rPr lang="es-VE" smtClean="0"/>
               <a:t>Click to edit Master text styles</a:t>
             </a:r>
           </a:p>
           <a:p>
             <a:pPr lvl="1"/>
             <a:r>
-              <a:rPr lang="en-US" smtClean="0"/>
+              <a:rPr lang="es-VE" smtClean="0"/>
               <a:t>Second level</a:t>
             </a:r>
           </a:p>
           <a:p>
             <a:pPr lvl="2"/>
             <a:r>
-              <a:rPr lang="en-US" smtClean="0"/>
+              <a:rPr lang="es-VE" smtClean="0"/>
               <a:t>Third level</a:t>
             </a:r>
           </a:p>
           <a:p>
             <a:pPr lvl="3"/>
             <a:r>
-              <a:rPr lang="en-US" smtClean="0"/>
+              <a:rPr lang="es-VE" smtClean="0"/>
               <a:t>Fourth level</a:t>
             </a:r>
           </a:p>
           <a:p>
             <a:pPr lvl="4"/>
             <a:r>
-              <a:rPr lang="en-US" smtClean="0"/>
+              <a:rPr lang="es-VE" smtClean="0"/>
               <a:t>Fifth level</a:t>
             </a:r>
-            <a:endParaRPr lang="en-US"/>
+            <a:endParaRPr lang="es-VE"/>
           </a:p>
         </p:txBody>
       </p:sp>
@@ -3008,10 +3008,10 @@
           <a:lstStyle/>
           <a:p>
             <a:fld id="{5BCAD085-E8A6-8845-BD4E-CB4CCA059FC4}" type="datetimeFigureOut">
-              <a:rPr lang="en-US" smtClean="0"/>
+              <a:rPr lang="es-VE" smtClean="0"/>
               <a:t>1/27/13</a:t>
             </a:fld>
-            <a:endParaRPr lang="en-US"/>
+            <a:endParaRPr lang="es-VE"/>
           </a:p>
         </p:txBody>
       </p:sp>
@@ -3030,7 +3030,7 @@
           <a:bodyPr/>
           <a:lstStyle/>
           <a:p>
-            <a:endParaRPr lang="en-US"/>
+            <a:endParaRPr lang="es-VE"/>
           </a:p>
         </p:txBody>
       </p:sp>
@@ -3050,10 +3050,10 @@
           <a:lstStyle/>
           <a:p>
             <a:fld id="{C1FF6DA9-008F-8B48-92A6-B652298478BF}" type="slidenum">
-              <a:rPr lang="en-US" smtClean="0"/>
+              <a:rPr lang="es-VE" smtClean="0"/>
               <a:t>‹#›</a:t>
             </a:fld>
-            <a:endParaRPr lang="en-US"/>
+            <a:endParaRPr lang="es-VE"/>
           </a:p>
         </p:txBody>
       </p:sp>
@@ -3103,10 +3103,10 @@
           <a:lstStyle/>
           <a:p>
             <a:r>
-              <a:rPr lang="en-US" smtClean="0"/>
+              <a:rPr lang="es-VE" smtClean="0"/>
               <a:t>Click to edit Master title style</a:t>
             </a:r>
-            <a:endParaRPr lang="en-US"/>
+            <a:endParaRPr lang="es-VE"/>
           </a:p>
         </p:txBody>
       </p:sp>
@@ -3126,10 +3126,10 @@
           <a:lstStyle/>
           <a:p>
             <a:fld id="{5BCAD085-E8A6-8845-BD4E-CB4CCA059FC4}" type="datetimeFigureOut">
-              <a:rPr lang="en-US" smtClean="0"/>
+              <a:rPr lang="es-VE" smtClean="0"/>
               <a:t>1/27/13</a:t>
             </a:fld>
-            <a:endParaRPr lang="en-US"/>
+            <a:endParaRPr lang="es-VE"/>
           </a:p>
         </p:txBody>
       </p:sp>
@@ -3148,7 +3148,7 @@
           <a:bodyPr/>
           <a:lstStyle/>
           <a:p>
-            <a:endParaRPr lang="en-US"/>
+            <a:endParaRPr lang="es-VE"/>
           </a:p>
         </p:txBody>
       </p:sp>
@@ -3168,10 +3168,10 @@
           <a:lstStyle/>
           <a:p>
             <a:fld id="{C1FF6DA9-008F-8B48-92A6-B652298478BF}" type="slidenum">
-              <a:rPr lang="en-US" smtClean="0"/>
+              <a:rPr lang="es-VE" smtClean="0"/>
               <a:t>‹#›</a:t>
             </a:fld>
-            <a:endParaRPr lang="en-US"/>
+            <a:endParaRPr lang="es-VE"/>
           </a:p>
         </p:txBody>
       </p:sp>
@@ -3221,10 +3221,10 @@
           <a:lstStyle/>
           <a:p>
             <a:fld id="{5BCAD085-E8A6-8845-BD4E-CB4CCA059FC4}" type="datetimeFigureOut">
-              <a:rPr lang="en-US" smtClean="0"/>
+              <a:rPr lang="es-VE" smtClean="0"/>
               <a:t>1/27/13</a:t>
             </a:fld>
-            <a:endParaRPr lang="en-US"/>
+            <a:endParaRPr lang="es-VE"/>
           </a:p>
         </p:txBody>
       </p:sp>
@@ -3243,7 +3243,7 @@
           <a:bodyPr/>
           <a:lstStyle/>
           <a:p>
-            <a:endParaRPr lang="en-US"/>
+            <a:endParaRPr lang="es-VE"/>
           </a:p>
         </p:txBody>
       </p:sp>
@@ -3263,10 +3263,10 @@
           <a:lstStyle/>
           <a:p>
             <a:fld id="{C1FF6DA9-008F-8B48-92A6-B652298478BF}" type="slidenum">
-              <a:rPr lang="en-US" smtClean="0"/>
+              <a:rPr lang="es-VE" smtClean="0"/>
               <a:t>‹#›</a:t>
             </a:fld>
-            <a:endParaRPr lang="en-US"/>
+            <a:endParaRPr lang="es-VE"/>
           </a:p>
         </p:txBody>
       </p:sp>
@@ -3320,15 +3320,15 @@
           <a:bodyPr anchor="b"/>
           <a:lstStyle>
             <a:lvl1pPr algn="l">
-              <a:defRPr sz="2000" b="1"/>
+              <a:defRPr sz="2000" b="1" lang="es-VE"/>
             </a:lvl1pPr>
           </a:lstStyle>
           <a:p>
             <a:r>
-              <a:rPr lang="en-US" smtClean="0"/>
+              <a:rPr lang="es-VE" smtClean="0"/>
               <a:t>Click to edit Master title style</a:t>
             </a:r>
-            <a:endParaRPr lang="en-US"/>
+            <a:endParaRPr lang="es-VE"/>
           </a:p>
         </p:txBody>
       </p:sp>
@@ -3352,68 +3352,68 @@
           <a:bodyPr/>
           <a:lstStyle>
             <a:lvl1pPr>
-              <a:defRPr sz="3200"/>
+              <a:defRPr sz="3200" lang="es-VE"/>
             </a:lvl1pPr>
             <a:lvl2pPr>
-              <a:defRPr sz="2800"/>
+              <a:defRPr sz="2800" lang="es-VE"/>
             </a:lvl2pPr>
             <a:lvl3pPr>
-              <a:defRPr sz="2400"/>
+              <a:defRPr sz="2400" lang="es-VE"/>
             </a:lvl3pPr>
             <a:lvl4pPr>
-              <a:defRPr sz="2000"/>
+              <a:defRPr sz="2000" lang="es-VE"/>
             </a:lvl4pPr>
             <a:lvl5pPr>
-              <a:defRPr sz="2000"/>
+              <a:defRPr sz="2000" lang="es-VE"/>
             </a:lvl5pPr>
             <a:lvl6pPr>
-              <a:defRPr sz="2000"/>
+              <a:defRPr sz="2000" lang="es-VE"/>
             </a:lvl6pPr>
             <a:lvl7pPr>
-              <a:defRPr sz="2000"/>
+              <a:defRPr sz="2000" lang="es-VE"/>
             </a:lvl7pPr>
             <a:lvl8pPr>
-              <a:defRPr sz="2000"/>
+              <a:defRPr sz="2000" lang="es-VE"/>
             </a:lvl8pPr>
             <a:lvl9pPr>
-              <a:defRPr sz="2000"/>
+              <a:defRPr sz="2000" lang="es-VE"/>
             </a:lvl9pPr>
           </a:lstStyle>
           <a:p>
             <a:pPr lvl="0"/>
             <a:r>
-              <a:rPr lang="en-US" smtClean="0"/>
+              <a:rPr lang="es-VE" smtClean="0"/>
               <a:t>Click to edit Master text styles</a:t>
             </a:r>
           </a:p>
           <a:p>
             <a:pPr lvl="1"/>
             <a:r>
-              <a:rPr lang="en-US" smtClean="0"/>
+              <a:rPr lang="es-VE" smtClean="0"/>
               <a:t>Second level</a:t>
             </a:r>
           </a:p>
           <a:p>
             <a:pPr lvl="2"/>
             <a:r>
-              <a:rPr lang="en-US" smtClean="0"/>
+              <a:rPr lang="es-VE" smtClean="0"/>
               <a:t>Third level</a:t>
             </a:r>
           </a:p>
           <a:p>
             <a:pPr lvl="3"/>
             <a:r>
-              <a:rPr lang="en-US" smtClean="0"/>
+              <a:rPr lang="es-VE" smtClean="0"/>
               <a:t>Fourth level</a:t>
             </a:r>
           </a:p>
           <a:p>
             <a:pPr lvl="4"/>
             <a:r>
-              <a:rPr lang="en-US" smtClean="0"/>
+              <a:rPr lang="es-VE" smtClean="0"/>
               <a:t>Fifth level</a:t>
             </a:r>
-            <a:endParaRPr lang="en-US"/>
+            <a:endParaRPr lang="es-VE"/>
           </a:p>
         </p:txBody>
       </p:sp>
@@ -3438,45 +3438,45 @@
           <a:lstStyle>
             <a:lvl1pPr marL="0" indent="0">
               <a:buNone/>
-              <a:defRPr sz="1400"/>
+              <a:defRPr sz="1400" lang="es-VE"/>
             </a:lvl1pPr>
             <a:lvl2pPr marL="457200" indent="0">
               <a:buNone/>
-              <a:defRPr sz="1200"/>
+              <a:defRPr sz="1200" lang="es-VE"/>
             </a:lvl2pPr>
             <a:lvl3pPr marL="914400" indent="0">
               <a:buNone/>
-              <a:defRPr sz="1000"/>
+              <a:defRPr sz="1000" lang="es-VE"/>
             </a:lvl3pPr>
             <a:lvl4pPr marL="1371600" indent="0">
               <a:buNone/>
-              <a:defRPr sz="900"/>
+              <a:defRPr sz="900" lang="es-VE"/>
             </a:lvl4pPr>
             <a:lvl5pPr marL="1828800" indent="0">
               <a:buNone/>
-              <a:defRPr sz="900"/>
+              <a:defRPr sz="900" lang="es-VE"/>
             </a:lvl5pPr>
             <a:lvl6pPr marL="2286000" indent="0">
               <a:buNone/>
-              <a:defRPr sz="900"/>
+              <a:defRPr sz="900" lang="es-VE"/>
             </a:lvl6pPr>
             <a:lvl7pPr marL="2743200" indent="0">
               <a:buNone/>
-              <a:defRPr sz="900"/>
+              <a:defRPr sz="900" lang="es-VE"/>
             </a:lvl7pPr>
             <a:lvl8pPr marL="3200400" indent="0">
               <a:buNone/>
-              <a:defRPr sz="900"/>
+              <a:defRPr sz="900" lang="es-VE"/>
             </a:lvl8pPr>
             <a:lvl9pPr marL="3657600" indent="0">
               <a:buNone/>
-              <a:defRPr sz="900"/>
+              <a:defRPr sz="900" lang="es-VE"/>
             </a:lvl9pPr>
           </a:lstStyle>
           <a:p>
             <a:pPr lvl="0"/>
             <a:r>
-              <a:rPr lang="en-US" smtClean="0"/>
+              <a:rPr lang="es-VE" smtClean="0"/>
               <a:t>Click to edit Master text styles</a:t>
             </a:r>
           </a:p>
@@ -3498,10 +3498,10 @@
           <a:lstStyle/>
           <a:p>
             <a:fld id="{5BCAD085-E8A6-8845-BD4E-CB4CCA059FC4}" type="datetimeFigureOut">
-              <a:rPr lang="en-US" smtClean="0"/>
+              <a:rPr lang="es-VE" smtClean="0"/>
               <a:t>1/27/13</a:t>
             </a:fld>
-            <a:endParaRPr lang="en-US"/>
+            <a:endParaRPr lang="es-VE"/>
           </a:p>
         </p:txBody>
       </p:sp>
@@ -3520,7 +3520,7 @@
           <a:bodyPr/>
           <a:lstStyle/>
           <a:p>
-            <a:endParaRPr lang="en-US"/>
+            <a:endParaRPr lang="es-VE"/>
           </a:p>
         </p:txBody>
       </p:sp>
@@ -3540,10 +3540,10 @@
           <a:lstStyle/>
           <a:p>
             <a:fld id="{C1FF6DA9-008F-8B48-92A6-B652298478BF}" type="slidenum">
-              <a:rPr lang="en-US" smtClean="0"/>
+              <a:rPr lang="es-VE" smtClean="0"/>
               <a:t>‹#›</a:t>
             </a:fld>
-            <a:endParaRPr lang="en-US"/>
+            <a:endParaRPr lang="es-VE"/>
           </a:p>
         </p:txBody>
       </p:sp>
@@ -3597,15 +3597,15 @@
           <a:bodyPr anchor="b"/>
           <a:lstStyle>
             <a:lvl1pPr algn="l">
-              <a:defRPr sz="2000" b="1"/>
+              <a:defRPr sz="2000" b="1" lang="es-VE"/>
             </a:lvl1pPr>
           </a:lstStyle>
           <a:p>
             <a:r>
-              <a:rPr lang="en-US" smtClean="0"/>
+              <a:rPr lang="es-VE" smtClean="0"/>
               <a:t>Click to edit Master title style</a:t>
             </a:r>
-            <a:endParaRPr lang="en-US"/>
+            <a:endParaRPr lang="es-VE"/>
           </a:p>
         </p:txBody>
       </p:sp>
@@ -3630,43 +3630,43 @@
           <a:lstStyle>
             <a:lvl1pPr marL="0" indent="0">
               <a:buNone/>
-              <a:defRPr sz="3200"/>
+              <a:defRPr sz="3200" lang="es-VE"/>
             </a:lvl1pPr>
             <a:lvl2pPr marL="457200" indent="0">
               <a:buNone/>
-              <a:defRPr sz="2800"/>
+              <a:defRPr sz="2800" lang="es-VE"/>
             </a:lvl2pPr>
             <a:lvl3pPr marL="914400" indent="0">
               <a:buNone/>
-              <a:defRPr sz="2400"/>
+              <a:defRPr sz="2400" lang="es-VE"/>
             </a:lvl3pPr>
             <a:lvl4pPr marL="1371600" indent="0">
               <a:buNone/>
-              <a:defRPr sz="2000"/>
+              <a:defRPr sz="2000" lang="es-VE"/>
             </a:lvl4pPr>
             <a:lvl5pPr marL="1828800" indent="0">
               <a:buNone/>
-              <a:defRPr sz="2000"/>
+              <a:defRPr sz="2000" lang="es-VE"/>
             </a:lvl5pPr>
             <a:lvl6pPr marL="2286000" indent="0">
               <a:buNone/>
-              <a:defRPr sz="2000"/>
+              <a:defRPr sz="2000" lang="es-VE"/>
             </a:lvl6pPr>
             <a:lvl7pPr marL="2743200" indent="0">
               <a:buNone/>
-              <a:defRPr sz="2000"/>
+              <a:defRPr sz="2000" lang="es-VE"/>
             </a:lvl7pPr>
             <a:lvl8pPr marL="3200400" indent="0">
               <a:buNone/>
-              <a:defRPr sz="2000"/>
+              <a:defRPr sz="2000" lang="es-VE"/>
             </a:lvl8pPr>
             <a:lvl9pPr marL="3657600" indent="0">
               <a:buNone/>
-              <a:defRPr sz="2000"/>
+              <a:defRPr sz="2000" lang="es-VE"/>
             </a:lvl9pPr>
           </a:lstStyle>
           <a:p>
-            <a:endParaRPr lang="en-US"/>
+            <a:endParaRPr lang="es-VE"/>
           </a:p>
         </p:txBody>
       </p:sp>
@@ -3691,45 +3691,45 @@
           <a:lstStyle>
             <a:lvl1pPr marL="0" indent="0">
               <a:buNone/>
-              <a:defRPr sz="1400"/>
+              <a:defRPr sz="1400" lang="es-VE"/>
             </a:lvl1pPr>
             <a:lvl2pPr marL="457200" indent="0">
               <a:buNone/>
-              <a:defRPr sz="1200"/>
+              <a:defRPr sz="1200" lang="es-VE"/>
             </a:lvl2pPr>
             <a:lvl3pPr marL="914400" indent="0">
               <a:buNone/>
-              <a:defRPr sz="1000"/>
+              <a:defRPr sz="1000" lang="es-VE"/>
             </a:lvl3pPr>
             <a:lvl4pPr marL="1371600" indent="0">
               <a:buNone/>
-              <a:defRPr sz="900"/>
+              <a:defRPr sz="900" lang="es-VE"/>
             </a:lvl4pPr>
             <a:lvl5pPr marL="1828800" indent="0">
               <a:buNone/>
-              <a:defRPr sz="900"/>
+              <a:defRPr sz="900" lang="es-VE"/>
             </a:lvl5pPr>
             <a:lvl6pPr marL="2286000" indent="0">
               <a:buNone/>
-              <a:defRPr sz="900"/>
+              <a:defRPr sz="900" lang="es-VE"/>
             </a:lvl6pPr>
             <a:lvl7pPr marL="2743200" indent="0">
               <a:buNone/>
-              <a:defRPr sz="900"/>
+              <a:defRPr sz="900" lang="es-VE"/>
             </a:lvl7pPr>
             <a:lvl8pPr marL="3200400" indent="0">
               <a:buNone/>
-              <a:defRPr sz="900"/>
+              <a:defRPr sz="900" lang="es-VE"/>
             </a:lvl8pPr>
             <a:lvl9pPr marL="3657600" indent="0">
               <a:buNone/>
-              <a:defRPr sz="900"/>
+              <a:defRPr sz="900" lang="es-VE"/>
             </a:lvl9pPr>
           </a:lstStyle>
           <a:p>
             <a:pPr lvl="0"/>
             <a:r>
-              <a:rPr lang="en-US" smtClean="0"/>
+              <a:rPr lang="es-VE" smtClean="0"/>
               <a:t>Click to edit Master text styles</a:t>
             </a:r>
           </a:p>
@@ -3751,10 +3751,10 @@
           <a:lstStyle/>
           <a:p>
             <a:fld id="{5BCAD085-E8A6-8845-BD4E-CB4CCA059FC4}" type="datetimeFigureOut">
-              <a:rPr lang="en-US" smtClean="0"/>
+              <a:rPr lang="es-VE" smtClean="0"/>
               <a:t>1/27/13</a:t>
             </a:fld>
-            <a:endParaRPr lang="en-US"/>
+            <a:endParaRPr lang="es-VE"/>
           </a:p>
         </p:txBody>
       </p:sp>
@@ -3773,7 +3773,7 @@
           <a:bodyPr/>
           <a:lstStyle/>
           <a:p>
-            <a:endParaRPr lang="en-US"/>
+            <a:endParaRPr lang="es-VE"/>
           </a:p>
         </p:txBody>
       </p:sp>
@@ -3793,10 +3793,10 @@
           <a:lstStyle/>
           <a:p>
             <a:fld id="{C1FF6DA9-008F-8B48-92A6-B652298478BF}" type="slidenum">
-              <a:rPr lang="en-US" smtClean="0"/>
+              <a:rPr lang="es-VE" smtClean="0"/>
               <a:t>‹#›</a:t>
             </a:fld>
-            <a:endParaRPr lang="en-US"/>
+            <a:endParaRPr lang="es-VE"/>
           </a:p>
         </p:txBody>
       </p:sp>
@@ -3864,10 +3864,10 @@
           <a:lstStyle/>
           <a:p>
             <a:r>
-              <a:rPr lang="en-US" smtClean="0"/>
+              <a:rPr lang="es-VE" smtClean="0"/>
               <a:t>Click to edit Master title style</a:t>
             </a:r>
-            <a:endParaRPr lang="en-US"/>
+            <a:endParaRPr lang="es-VE"/>
           </a:p>
         </p:txBody>
       </p:sp>
@@ -3898,38 +3898,38 @@
           <a:p>
             <a:pPr lvl="0"/>
             <a:r>
-              <a:rPr lang="en-US" smtClean="0"/>
+              <a:rPr lang="es-VE" smtClean="0"/>
               <a:t>Click to edit Master text styles</a:t>
             </a:r>
           </a:p>
           <a:p>
             <a:pPr lvl="1"/>
             <a:r>
-              <a:rPr lang="en-US" smtClean="0"/>
+              <a:rPr lang="es-VE" smtClean="0"/>
               <a:t>Second level</a:t>
             </a:r>
           </a:p>
           <a:p>
             <a:pPr lvl="2"/>
             <a:r>
-              <a:rPr lang="en-US" smtClean="0"/>
+              <a:rPr lang="es-VE" smtClean="0"/>
               <a:t>Third level</a:t>
             </a:r>
           </a:p>
           <a:p>
             <a:pPr lvl="3"/>
             <a:r>
-              <a:rPr lang="en-US" smtClean="0"/>
+              <a:rPr lang="es-VE" smtClean="0"/>
               <a:t>Fourth level</a:t>
             </a:r>
           </a:p>
           <a:p>
             <a:pPr lvl="4"/>
             <a:r>
-              <a:rPr lang="en-US" smtClean="0"/>
+              <a:rPr lang="es-VE" smtClean="0"/>
               <a:t>Fifth level</a:t>
             </a:r>
-            <a:endParaRPr lang="en-US"/>
+            <a:endParaRPr lang="es-VE"/>
           </a:p>
         </p:txBody>
       </p:sp>
@@ -3956,7 +3956,7 @@
           <a:bodyPr vert="horz" lIns="91440" tIns="45720" rIns="91440" bIns="45720" rtlCol="0" anchor="ctr"/>
           <a:lstStyle>
             <a:lvl1pPr algn="l">
-              <a:defRPr sz="1200">
+              <a:defRPr sz="1200" lang="es-VE">
                 <a:solidFill>
                   <a:schemeClr val="tx1">
                     <a:tint val="75000"/>
@@ -3967,10 +3967,10 @@
           </a:lstStyle>
           <a:p>
             <a:fld id="{5BCAD085-E8A6-8845-BD4E-CB4CCA059FC4}" type="datetimeFigureOut">
-              <a:rPr lang="en-US" smtClean="0"/>
+              <a:rPr lang="es-VE" smtClean="0"/>
               <a:t>1/27/13</a:t>
             </a:fld>
-            <a:endParaRPr lang="en-US"/>
+            <a:endParaRPr lang="es-VE"/>
           </a:p>
         </p:txBody>
       </p:sp>
@@ -3997,7 +3997,7 @@
           <a:bodyPr vert="horz" lIns="91440" tIns="45720" rIns="91440" bIns="45720" rtlCol="0" anchor="ctr"/>
           <a:lstStyle>
             <a:lvl1pPr algn="ctr">
-              <a:defRPr sz="1200">
+              <a:defRPr sz="1200" lang="es-VE">
                 <a:solidFill>
                   <a:schemeClr val="tx1">
                     <a:tint val="75000"/>
@@ -4007,7 +4007,7 @@
             </a:lvl1pPr>
           </a:lstStyle>
           <a:p>
-            <a:endParaRPr lang="en-US"/>
+            <a:endParaRPr lang="es-VE"/>
           </a:p>
         </p:txBody>
       </p:sp>
@@ -4034,7 +4034,7 @@
           <a:bodyPr vert="horz" lIns="91440" tIns="45720" rIns="91440" bIns="45720" rtlCol="0" anchor="ctr"/>
           <a:lstStyle>
             <a:lvl1pPr algn="r">
-              <a:defRPr sz="1200">
+              <a:defRPr sz="1200" lang="es-VE">
                 <a:solidFill>
                   <a:schemeClr val="tx1">
                     <a:tint val="75000"/>
@@ -4045,10 +4045,10 @@
           </a:lstStyle>
           <a:p>
             <a:fld id="{C1FF6DA9-008F-8B48-92A6-B652298478BF}" type="slidenum">
-              <a:rPr lang="en-US" smtClean="0"/>
+              <a:rPr lang="es-VE" smtClean="0"/>
               <a:t>‹#›</a:t>
             </a:fld>
-            <a:endParaRPr lang="en-US"/>
+            <a:endParaRPr lang="es-VE"/>
           </a:p>
         </p:txBody>
       </p:sp>
@@ -4080,7 +4080,7 @@
           <a:spcPct val="0"/>
         </a:spcBef>
         <a:buNone/>
-        <a:defRPr sz="2600" kern="1200" b="1">
+        <a:defRPr sz="2600" kern="1200" b="1" lang="es-VE">
           <a:solidFill>
             <a:schemeClr val="tx1"/>
           </a:solidFill>
@@ -4097,7 +4097,7 @@
         </a:spcBef>
         <a:buFont typeface="Arial"/>
         <a:buChar char="•"/>
-        <a:defRPr sz="2000" kern="1200">
+        <a:defRPr sz="2000" kern="1200" lang="es-VE">
           <a:solidFill>
             <a:schemeClr val="tx1"/>
           </a:solidFill>
@@ -4112,7 +4112,7 @@
         </a:spcBef>
         <a:buFont typeface="Arial"/>
         <a:buChar char="–"/>
-        <a:defRPr sz="1800" kern="1200">
+        <a:defRPr sz="1800" kern="1200" lang="es-VE">
           <a:solidFill>
             <a:schemeClr val="tx1"/>
           </a:solidFill>
@@ -4127,7 +4127,7 @@
         </a:spcBef>
         <a:buFont typeface="Arial"/>
         <a:buChar char="•"/>
-        <a:defRPr sz="1600" kern="1200">
+        <a:defRPr sz="1600" kern="1200" lang="es-VE">
           <a:solidFill>
             <a:schemeClr val="tx1"/>
           </a:solidFill>
@@ -4142,7 +4142,7 @@
         </a:spcBef>
         <a:buFont typeface="Arial"/>
         <a:buChar char="–"/>
-        <a:defRPr sz="2000" kern="1200">
+        <a:defRPr sz="2000" kern="1200" lang="es-VE">
           <a:solidFill>
             <a:schemeClr val="tx1"/>
           </a:solidFill>
@@ -4157,7 +4157,7 @@
         </a:spcBef>
         <a:buFont typeface="Arial"/>
         <a:buChar char="»"/>
-        <a:defRPr sz="2000" kern="1200">
+        <a:defRPr sz="2000" kern="1200" lang="es-VE">
           <a:solidFill>
             <a:schemeClr val="tx1"/>
           </a:solidFill>
@@ -4172,7 +4172,7 @@
         </a:spcBef>
         <a:buFont typeface="Arial"/>
         <a:buChar char="•"/>
-        <a:defRPr sz="2000" kern="1200">
+        <a:defRPr sz="2000" kern="1200" lang="es-VE">
           <a:solidFill>
             <a:schemeClr val="tx1"/>
           </a:solidFill>
@@ -4187,7 +4187,7 @@
         </a:spcBef>
         <a:buFont typeface="Arial"/>
         <a:buChar char="•"/>
-        <a:defRPr sz="2000" kern="1200">
+        <a:defRPr sz="2000" kern="1200" lang="es-VE">
           <a:solidFill>
             <a:schemeClr val="tx1"/>
           </a:solidFill>
@@ -4202,7 +4202,7 @@
         </a:spcBef>
         <a:buFont typeface="Arial"/>
         <a:buChar char="•"/>
-        <a:defRPr sz="2000" kern="1200">
+        <a:defRPr sz="2000" kern="1200" lang="es-VE">
           <a:solidFill>
             <a:schemeClr val="tx1"/>
           </a:solidFill>
@@ -4217,7 +4217,7 @@
         </a:spcBef>
         <a:buFont typeface="Arial"/>
         <a:buChar char="•"/>
-        <a:defRPr sz="2000" kern="1200">
+        <a:defRPr sz="2000" kern="1200" lang="es-VE">
           <a:solidFill>
             <a:schemeClr val="tx1"/>
           </a:solidFill>
@@ -4229,10 +4229,10 @@
     </p:bodyStyle>
     <p:otherStyle>
       <a:defPPr>
-        <a:defRPr lang="en-US"/>
+        <a:defRPr lang="es-VE"/>
       </a:defPPr>
       <a:lvl1pPr marL="0" algn="l" defTabSz="457200" rtl="0" eaLnBrk="1" latinLnBrk="0" hangingPunct="1">
-        <a:defRPr sz="1800" kern="1200">
+        <a:defRPr sz="1800" kern="1200" lang="es-VE">
           <a:solidFill>
             <a:schemeClr val="tx1"/>
           </a:solidFill>
@@ -4242,7 +4242,7 @@
         </a:defRPr>
       </a:lvl1pPr>
       <a:lvl2pPr marL="457200" algn="l" defTabSz="457200" rtl="0" eaLnBrk="1" latinLnBrk="0" hangingPunct="1">
-        <a:defRPr sz="1800" kern="1200">
+        <a:defRPr sz="1800" kern="1200" lang="es-VE">
           <a:solidFill>
             <a:schemeClr val="tx1"/>
           </a:solidFill>
@@ -4252,7 +4252,7 @@
         </a:defRPr>
       </a:lvl2pPr>
       <a:lvl3pPr marL="914400" algn="l" defTabSz="457200" rtl="0" eaLnBrk="1" latinLnBrk="0" hangingPunct="1">
-        <a:defRPr sz="1800" kern="1200">
+        <a:defRPr sz="1800" kern="1200" lang="es-VE">
           <a:solidFill>
             <a:schemeClr val="tx1"/>
           </a:solidFill>
@@ -4262,7 +4262,7 @@
         </a:defRPr>
       </a:lvl3pPr>
       <a:lvl4pPr marL="1371600" algn="l" defTabSz="457200" rtl="0" eaLnBrk="1" latinLnBrk="0" hangingPunct="1">
-        <a:defRPr sz="1800" kern="1200">
+        <a:defRPr sz="1800" kern="1200" lang="es-VE">
           <a:solidFill>
             <a:schemeClr val="tx1"/>
           </a:solidFill>
@@ -4272,7 +4272,7 @@
         </a:defRPr>
       </a:lvl4pPr>
       <a:lvl5pPr marL="1828800" algn="l" defTabSz="457200" rtl="0" eaLnBrk="1" latinLnBrk="0" hangingPunct="1">
-        <a:defRPr sz="1800" kern="1200">
+        <a:defRPr sz="1800" kern="1200" lang="es-VE">
           <a:solidFill>
             <a:schemeClr val="tx1"/>
           </a:solidFill>
@@ -4282,7 +4282,7 @@
         </a:defRPr>
       </a:lvl5pPr>
       <a:lvl6pPr marL="2286000" algn="l" defTabSz="457200" rtl="0" eaLnBrk="1" latinLnBrk="0" hangingPunct="1">
-        <a:defRPr sz="1800" kern="1200">
+        <a:defRPr sz="1800" kern="1200" lang="es-VE">
           <a:solidFill>
             <a:schemeClr val="tx1"/>
           </a:solidFill>
@@ -4292,7 +4292,7 @@
         </a:defRPr>
       </a:lvl6pPr>
       <a:lvl7pPr marL="2743200" algn="l" defTabSz="457200" rtl="0" eaLnBrk="1" latinLnBrk="0" hangingPunct="1">
-        <a:defRPr sz="1800" kern="1200">
+        <a:defRPr sz="1800" kern="1200" lang="es-VE">
           <a:solidFill>
             <a:schemeClr val="tx1"/>
           </a:solidFill>
@@ -4302,7 +4302,7 @@
         </a:defRPr>
       </a:lvl7pPr>
       <a:lvl8pPr marL="3200400" algn="l" defTabSz="457200" rtl="0" eaLnBrk="1" latinLnBrk="0" hangingPunct="1">
-        <a:defRPr sz="1800" kern="1200">
+        <a:defRPr sz="1800" kern="1200" lang="es-VE">
           <a:solidFill>
             <a:schemeClr val="tx1"/>
           </a:solidFill>
@@ -4312,7 +4312,7 @@
         </a:defRPr>
       </a:lvl8pPr>
       <a:lvl9pPr marL="3657600" algn="l" defTabSz="457200" rtl="0" eaLnBrk="1" latinLnBrk="0" hangingPunct="1">
-        <a:defRPr sz="1800" kern="1200">
+        <a:defRPr sz="1800" kern="1200" lang="es-VE">
           <a:solidFill>
             <a:schemeClr val="tx1"/>
           </a:solidFill>
@@ -4500,7 +4500,7 @@
                   <a:srgbClr val="1F2328"/>
                 </a:solidFill>
               </a:rPr>
-              <a:t>Qué vigilar a continuación</a:t>
+              <a:t>Qué vigilar en las próximas semanas</a:t>
             </a:r>
           </a:p>
         </p:txBody>
@@ -4587,7 +4587,7 @@
                   <a:srgbClr val="1F2328"/>
                 </a:solidFill>
               </a:rPr>
-              <a:t>Alertas en los cultivos del noroeste y el nordeste (JRC ASAP, cada diez días)</a:t>
+              <a:t>Alertas en los cultivos del noroeste y del nororiente (JRC ASAP, cada diez días)</a:t>
             </a:r>
           </a:p>
         </p:txBody>
@@ -5006,7 +5006,7 @@
                   <a:srgbClr val="1F2328"/>
                 </a:solidFill>
               </a:rPr>
-              <a:t>La lluvia de mayo–septiembre fue del 65–89% de lo normal, entre las cinco más bajas desde 1981. Los cultivos están por debajo del umbral de alerta en Sucre, Zulia y Falcón. Guri está casi lleno.</a:t>
+              <a:t>La lluvia de mayo–septiembre fue del 65–89% de lo normal, entre las cinco más bajas desde 1981. Los cultivos están por debajo del umbral de alerta en Sucre, Zulia y Falcón. El Guri está casi lleno.</a:t>
             </a:r>
           </a:p>
         </p:txBody>
@@ -5534,7 +5534,7 @@
                   <a:srgbClr val="1F2328"/>
                 </a:solidFill>
               </a:rPr>
-              <a:t>Con El Niño también hubo menos inundaciones registradas, más bajada del Guri y peor vegetación en la estación seca</a:t>
+              <a:t>Con El Niño también hubo menos inundaciones registradas, mayor bajada del Guri y peor vegetación en la estación seca</a:t>
             </a:r>
           </a:p>
         </p:txBody>
@@ -6396,7 +6396,7 @@
                   <a:srgbClr val="1F2328"/>
                 </a:solidFill>
               </a:rPr>
-              <a:t>Guri está casi lleno (270,2 m); bajadas como tras otros años de El Niño lo llevarían a 250–261 m en mayo de 2027</a:t>
+              <a:t>El Guri está casi lleno (270,2 m); bajadas como tras años de El Niño anteriores lo llevarían a 250–261 m en mayo de 2027</a:t>
             </a:r>
           </a:p>
         </p:txBody>
@@ -6631,7 +6631,7 @@
                   <a:srgbClr val="5B6168"/>
                 </a:solidFill>
               </a:rPr>
-              <a:t>SEAS5 de ECMWF, emitido en octubre de 2026, sin tendencia; clases como en el visor seas5-skill del equipo.</a:t>
+              <a:t>SEAS5 de ECMWF, emitido en octubre de 2026, con la tendencia de largo plazo quitada; clases como en el visor seas5-skill del equipo.</a:t>
             </a:r>
           </a:p>
         </p:txBody>
@@ -6861,14 +6861,14 @@
                   <a:srgbClr val="5B6168"/>
                 </a:solidFill>
               </a:rPr>
-              <a:t>FEWS NET: calendario estacional (página de Venezuela, en inglés) e informe sobre El Niño, agosto de 2026.</a:t>
+              <a:t>Calendario redibujado de la página de Venezuela de FEWS NET; perspectivas del informe de FEWS NET sobre El Niño, agosto de 2026.</a:t>
             </a:r>
           </a:p>
         </p:txBody>
       </p:sp>
       <p:pic>
         <p:nvPicPr>
-          <p:cNvPr id="5" name="Picture 4" descr="ve_seasonal_calendar_rural.png"/>
+          <p:cNvPr id="5" name="Picture 4" descr="calendar_slide.png"/>
           <p:cNvPicPr>
             <a:picLocks noChangeAspect="1"/>
           </p:cNvPicPr>
@@ -6882,8 +6882,8 @@
         </p:blipFill>
         <p:spPr>
           <a:xfrm>
-            <a:off x="548640" y="1920240"/>
-            <a:ext cx="7498079" cy="3740708"/>
+            <a:off x="411480" y="1920240"/>
+            <a:ext cx="8138160" cy="3248125"/>
           </a:xfrm>
           <a:prstGeom prst="rect">
             <a:avLst/>
@@ -6898,8 +6898,8 @@
         </p:nvSpPr>
         <p:spPr>
           <a:xfrm>
-            <a:off x="8321040" y="2011680"/>
-            <a:ext cx="3337560" cy="4023360"/>
+            <a:off x="8732520" y="2011680"/>
+            <a:ext cx="2971800" cy="4114800"/>
           </a:xfrm>
           <a:prstGeom prst="rect">
             <a:avLst/>
@@ -6919,7 +6919,7 @@
               <a:buChar char="•"/>
             </a:pPr>
             <a:r>
-              <a:rPr sz="1700" lang="es-VE">
+              <a:rPr sz="1600" lang="es-VE">
                 <a:solidFill>
                   <a:srgbClr val="1F2328"/>
                 </a:solidFill>
@@ -6935,7 +6935,7 @@
               <a:buChar char="•"/>
             </a:pPr>
             <a:r>
-              <a:rPr sz="1700" lang="es-VE">
+              <a:rPr sz="1600" lang="es-VE">
                 <a:solidFill>
                   <a:srgbClr val="1F2328"/>
                 </a:solidFill>
@@ -6951,7 +6951,7 @@
               <a:buChar char="•"/>
             </a:pPr>
             <a:r>
-              <a:rPr sz="1700" lang="es-VE">
+              <a:rPr sz="1600" lang="es-VE">
                 <a:solidFill>
                   <a:srgbClr val="1F2328"/>
                 </a:solidFill>

</xml_diff>